<commit_message>
Deck edits: fix slide 4 bullet; two-phase flow (slide 7); corpus->content; Terraform/CI-CD wording; add Resources (old vs new) slide; 2 models (Titan+Claude), optional 3rd
</commit_message>
<xml_diff>
--- a/SPARKS_AI_Search_Deck.pptx
+++ b/SPARKS_AI_Search_Deck.pptx
@@ -8,22 +8,23 @@
     <p:notesMasterId r:id="rId18"/>
   </p:notesMasterIdLst>
   <p:sldIdLst>
-    <p:sldId id="257" r:id="rId2"/>
-    <p:sldId id="258" r:id="rId3"/>
-    <p:sldId id="259" r:id="rId4"/>
-    <p:sldId id="260" r:id="rId5"/>
-    <p:sldId id="261" r:id="rId6"/>
-    <p:sldId id="262" r:id="rId7"/>
-    <p:sldId id="263" r:id="rId8"/>
-    <p:sldId id="264" r:id="rId9"/>
-    <p:sldId id="265" r:id="rId10"/>
-    <p:sldId id="266" r:id="rId11"/>
-    <p:sldId id="267" r:id="rId12"/>
-    <p:sldId id="268" r:id="rId13"/>
-    <p:sldId id="269" r:id="rId14"/>
-    <p:sldId id="270" r:id="rId15"/>
-    <p:sldId id="271" r:id="rId16"/>
-    <p:sldId id="272" r:id="rId17"/>
+    <p:sldId id="257" r:id="rIdSL1"/>
+    <p:sldId id="258" r:id="rIdSL2"/>
+    <p:sldId id="259" r:id="rIdSL3"/>
+    <p:sldId id="260" r:id="rIdSL4"/>
+    <p:sldId id="261" r:id="rIdSL5"/>
+    <p:sldId id="262" r:id="rIdSL6"/>
+    <p:sldId id="263" r:id="rIdSL7"/>
+    <p:sldId id="264" r:id="rIdSL8"/>
+    <p:sldId id="265" r:id="rIdSL9"/>
+    <p:sldId id="266" r:id="rIdSL10"/>
+    <p:sldId id="267" r:id="rIdSL11"/>
+    <p:sldId id="268" r:id="rIdSL12"/>
+    <p:sldId id="269" r:id="rIdSL13"/>
+    <p:sldId id="270" r:id="rIdSL14"/>
+    <p:sldId id="271" r:id="rIdSL15"/>
+    <p:sldId id="272" r:id="rIdSL16"/>
+    <p:sldId id="273" r:id="rIdSL17"/>
   </p:sldIdLst>
   <p:sldSz cx="9144000" cy="6858000" type="screen4x3"/>
   <p:notesSz cx="6858000" cy="9144000"/>
@@ -4726,7 +4727,7 @@
           <a:p>
             <a:r>
               <a:rPr lang="en-US" sz="2400" dirty="0"/>
-              <a:t>IaC: modular Terraform or Jenkins- one toggle switches Option 1 and Option 2; nothing applies until approved.</a:t>
+              <a:t>IaC: modular Terraform (deployed via CI/CD, e.g. Jenkins) - one toggle switches Option 1 and Option 2; nothing applies until approved.</a:t>
             </a:r>
           </a:p>
           <a:p>
@@ -4779,7 +4780,7 @@
           <a:p>
             <a:r>
               <a:rPr lang="en-US" dirty="0"/>
-              <a:t>Recommendation &amp; roadmap</a:t>
+              <a:t>Resources - old vs. new</a:t>
             </a:r>
           </a:p>
         </p:txBody>
@@ -4796,38 +4797,36 @@
         </p:nvSpPr>
         <p:spPr/>
         <p:txBody>
-          <a:bodyPr>
-            <a:normAutofit/>
-          </a:bodyPr>
-          <a:lstStyle/>
-          <a:p>
-            <a:r>
-              <a:rPr lang="en-US" sz="2400" dirty="0"/>
-              <a:t>Recommendation: build Option 1 (RAG) first - governable near-term value - so Option 2 (Agentic) is additive.</a:t>
-            </a:r>
-          </a:p>
-          <a:p>
-            <a:r>
-              <a:rPr lang="en-US" sz="2400" dirty="0"/>
-              <a:t>Phase 0 Foundations: approvals + provision Dev via IaC (gated).</a:t>
-            </a:r>
-          </a:p>
-          <a:p>
-            <a:r>
-              <a:rPr lang="en-US" sz="2400" dirty="0"/>
-              <a:t>Phase 1 RAG MVP: Ask SPARKS chat box with citations (capped Dev).</a:t>
-            </a:r>
-          </a:p>
-          <a:p>
-            <a:r>
-              <a:rPr lang="en-US" sz="2400" dirty="0"/>
-              <a:t>Phase 2 Enrich + evaluate: richer corpus + golden-set gate (small).</a:t>
-            </a:r>
-          </a:p>
-          <a:p>
-            <a:r>
-              <a:rPr lang="en-US" sz="2400" dirty="0"/>
-              <a:t>Phase 3 Agentic (Option 2): agent + tools for multi-step questions (higher).</a:t>
+          <a:bodyPr/>
+          <a:lstStyle/>
+          <a:p>
+            <a:r>
+              <a:rPr lang="en-US" dirty="0"/>
+              <a:t>EXISTING (reused, untouched): RDS/PostgreSQL + builders; open_search_json outbox; 2 indexer Lambdas; SQS FIFO; OpenSearch sparks-stage (8 indexes); API Gateway + Okta Lambda Authorizer.</a:t>
+            </a:r>
+          </a:p>
+          <a:p>
+            <a:r>
+              <a:rPr lang="en-US" dirty="0"/>
+              <a:t>NEW - Option 1 (RAG): 1 S3 bucket (8 domain folders); 2 Lambdas (extractor, Ask-SPARKS); 1 Bedrock Knowledge Base; 1 vector index (OpenSearch Serverless); 1 Guardrail; /ask API route (existing authorizer).</a:t>
+            </a:r>
+          </a:p>
+          <a:p>
+            <a:r>
+              <a:rPr lang="en-US" dirty="0"/>
+              <a:t>Bedrock models: 2 (Amazon Titan = embeddings, Claude = answers). Optional 3rd (Claude Haiku) later for cost. Models are invoked pay-per-token - nothing to host.</a:t>
+            </a:r>
+          </a:p>
+          <a:p>
+            <a:r>
+              <a:rPr lang="en-US" dirty="0"/>
+              <a:t>NEW - Option 2 (Agentic, additive): 1 Bedrock Agent; 3 tool Lambdas (semanticSearch, openSearchSearch, getInvestigation/Vehicle/Equipment); 3 Action Groups; 3 read-only RDS views. Reuses Option 1's S3, KB, vector index, Claude.</a:t>
+            </a:r>
+          </a:p>
+          <a:p>
+            <a:r>
+              <a:rPr lang="en-US" dirty="0"/>
+              <a:t>Supporting: KMS key, SQS DLQ, SSM watermark, 1 refresh schedule, CloudWatch dashboard + AWS Budget cap.</a:t>
             </a:r>
           </a:p>
         </p:txBody>
@@ -4874,6 +4873,101 @@
           <a:p>
             <a:r>
               <a:rPr lang="en-US" dirty="0"/>
+              <a:t>Recommendation &amp; roadmap</a:t>
+            </a:r>
+          </a:p>
+        </p:txBody>
+      </p:sp>
+      <p:sp>
+        <p:nvSpPr>
+          <p:cNvPr id="3" name="Content Placeholder 2"/>
+          <p:cNvSpPr>
+            <a:spLocks noGrp="1"/>
+          </p:cNvSpPr>
+          <p:nvPr>
+            <p:ph idx="1"/>
+          </p:nvPr>
+        </p:nvSpPr>
+        <p:spPr/>
+        <p:txBody>
+          <a:bodyPr>
+            <a:normAutofit/>
+          </a:bodyPr>
+          <a:lstStyle/>
+          <a:p>
+            <a:r>
+              <a:rPr lang="en-US" sz="2400" dirty="0"/>
+              <a:t>Recommendation: build Option 1 (RAG) first - governable near-term value - so Option 2 (Agentic) is additive.</a:t>
+            </a:r>
+          </a:p>
+          <a:p>
+            <a:r>
+              <a:rPr lang="en-US" sz="2400" dirty="0"/>
+              <a:t>Phase 0 Foundations: approvals + provision Dev via IaC (gated).</a:t>
+            </a:r>
+          </a:p>
+          <a:p>
+            <a:r>
+              <a:rPr lang="en-US" sz="2400" dirty="0"/>
+              <a:t>Phase 1 RAG MVP: Ask SPARKS chat box with citations (capped Dev).</a:t>
+            </a:r>
+          </a:p>
+          <a:p>
+            <a:r>
+              <a:rPr lang="en-US" sz="2400" dirty="0"/>
+              <a:t>Phase 2 Enrich + evaluate: richer search content + golden-set gate (small).</a:t>
+            </a:r>
+          </a:p>
+          <a:p>
+            <a:r>
+              <a:rPr lang="en-US" sz="2400" dirty="0"/>
+              <a:t>Phase 3 Agentic (Option 2): agent + tools for multi-step questions (higher).</a:t>
+            </a:r>
+          </a:p>
+        </p:txBody>
+      </p:sp>
+    </p:spTree>
+  </p:cSld>
+  <p:clrMapOvr>
+    <a:masterClrMapping/>
+  </p:clrMapOvr>
+</p:sld>
+</file>
+
+<file path=ppt/slides/slide17.xml><?xml version="1.0" encoding="utf-8"?>
+<p:sld xmlns:a="http://schemas.openxmlformats.org/drawingml/2006/main" xmlns:r="http://schemas.openxmlformats.org/officeDocument/2006/relationships" xmlns:p="http://schemas.openxmlformats.org/presentationml/2006/main">
+  <p:cSld>
+    <p:spTree>
+      <p:nvGrpSpPr>
+        <p:cNvPr id="1" name=""/>
+        <p:cNvGrpSpPr/>
+        <p:nvPr/>
+      </p:nvGrpSpPr>
+      <p:grpSpPr>
+        <a:xfrm>
+          <a:off x="0" y="0"/>
+          <a:ext cx="0" cy="0"/>
+          <a:chOff x="0" y="0"/>
+          <a:chExt cx="0" cy="0"/>
+        </a:xfrm>
+      </p:grpSpPr>
+      <p:sp>
+        <p:nvSpPr>
+          <p:cNvPr id="2" name="Title 1"/>
+          <p:cNvSpPr>
+            <a:spLocks noGrp="1"/>
+          </p:cNvSpPr>
+          <p:nvPr>
+            <p:ph type="title"/>
+          </p:nvPr>
+        </p:nvSpPr>
+        <p:spPr/>
+        <p:txBody>
+          <a:bodyPr/>
+          <a:lstStyle/>
+          <a:p>
+            <a:r>
+              <a:rPr lang="en-US" dirty="0"/>
               <a:t>The next steps</a:t>
             </a:r>
           </a:p>
@@ -5179,40 +5273,32 @@
           <a:lstStyle/>
           <a:p>
             <a:r>
-              <a:rPr lang="en-US" sz="2400" dirty="0"/>
+              <a:rPr lang="en-US" dirty="0"/>
               <a:t>PostgreSQL builders write denormalized documents to the open_search_json outbox.</a:t>
             </a:r>
           </a:p>
           <a:p>
             <a:r>
-              <a:rPr lang="en-US" sz="2400" dirty="0"/>
+              <a:rPr lang="en-US" dirty="0"/>
               <a:t>A scheduled pipeline (EventBridge, Lambda, SQS, Lambda) indexes them into Amazon OpenSearch.</a:t>
             </a:r>
           </a:p>
           <a:p>
             <a:r>
-              <a:rPr lang="en-US" sz="2400" dirty="0"/>
+              <a:rPr lang="en-US" dirty="0"/>
               <a:t>Users search via pills / filters / keyword over 8 indexes (vehicle, equipment, investigations, legacy).</a:t>
             </a:r>
           </a:p>
           <a:p>
             <a:r>
-              <a:rPr lang="en-US" sz="2400" dirty="0"/>
+              <a:rPr lang="en-US" dirty="0"/>
               <a:t>Strength: excellent at exact, structured lookups.</a:t>
             </a:r>
           </a:p>
           <a:p>
             <a:r>
-              <a:rPr lang="en-US" sz="2400" dirty="0"/>
-              <a:t>Every document already carries a uniqueId (e.g.</a:t>
-            </a:r>
-            <a:r>
               <a:rPr lang="en-US" dirty="0"/>
-              <a:t> </a:t>
-            </a:r>
-            <a:r>
-              <a:rPr lang="en-US" sz="2400" dirty="0"/>
-              <a:t>legacy_equipment:12251) - a ready-made citation key.</a:t>
+              <a:t>Every document already carries a uniqueId (e.g. legacy_equipment:12251) - a ready-made citation key.</a:t>
             </a:r>
           </a:p>
         </p:txBody>
@@ -5487,13 +5573,13 @@
           <a:p>
             <a:r>
               <a:rPr lang="en-US" sz="2400" dirty="0"/>
-              <a:t>How: read-only extractor -&gt; curated S3 object -&gt; Bedrock Knowledge Base (embed) -&gt; vector store -&gt; Claude.</a:t>
+              <a:t>Prepare (scheduled): read-only extractor -&gt; curated S3 search content -&gt; Bedrock Knowledge Base embeds -&gt; vector index.</a:t>
             </a:r>
           </a:p>
           <a:p>
             <a:r>
               <a:rPr lang="en-US" sz="2400" dirty="0"/>
-              <a:t>Exact/filter still uses existing OpenSearch; semantic uses RAG.</a:t>
+              <a:t>Answer (live): user question -&gt; retrieve top matches from vector index -&gt; Claude writes a grounded answer. Exact/filter still uses existing OpenSearch.</a:t>
             </a:r>
           </a:p>
           <a:p>
@@ -5580,7 +5666,7 @@
           <a:p>
             <a:r>
               <a:rPr lang="en-US" sz="2400" dirty="0"/>
-              <a:t>Tool: semanticSearch() - the Option 1 vector corpus.</a:t>
+              <a:t>Tool: semanticSearch() - the Option 1 vector index.</a:t>
             </a:r>
           </a:p>
           <a:p>
@@ -5592,7 +5678,7 @@
           <a:p>
             <a:r>
               <a:rPr lang="en-US" sz="2400" dirty="0"/>
-              <a:t>Best for complex, multi-step questions. An evolution of Option 1 - same corpus, same citations.</a:t>
+              <a:t>Best for complex, multi-step questions. An evolution of Option 1 - same content, same citations.</a:t>
             </a:r>
           </a:p>
         </p:txBody>

</xml_diff>

<commit_message>
Clarify deck cost slide (slide 12) with ballpark numbers
Replaced vague 'tens of dollars' / 'a few times that' with concrete planning estimates:
- One-time setup (embed all docs): ~$5-$20, once; then only changed docs
- Per question: ~1-3 cents (Option 1 / RAG), ~4-10 cents (Option 2 / Agentic)
- Monthly Dev pilot (~200 q/day): ~$50-$150 + ~$10-$30 vector storage
- Guardrail: AWS Budgets hard cap; estimates to be confirmed vs real doc counts + Bedrock rates
Still $0 today. Valid Microsoft PowerPoint 2007+.
</commit_message>
<xml_diff>
--- a/SPARKS_AI_Search_Deck.pptx
+++ b/SPARKS_AI_Search_Deck.pptx
@@ -4535,25 +4535,25 @@
           <a:p>
             <a:r>
               <a:rPr lang="en-US" sz="2400" dirty="0"/>
-              <a:t>After approval (Dev pilot, estimates): one-time embedding ~tens of dollars (one time).</a:t>
+              <a:t>One-time setup (embed all docs): about $5-$20 total, once - then only changed docs re-embed (pennies).</a:t>
             </a:r>
           </a:p>
           <a:p>
             <a:r>
               <a:rPr lang="en-US" sz="2400" dirty="0"/>
-              <a:t>Per query: cents (Option 1); a few times that for Option 2 (more LLM turns).</a:t>
+              <a:t>Per question: ~1-3 cents (Option 1 / RAG); ~4-10 cents (Option 2 / Agentic - more LLM turns).</a:t>
             </a:r>
           </a:p>
           <a:p>
             <a:r>
               <a:rPr lang="en-US" sz="2400" dirty="0"/>
-              <a:t>Monthly Dev pilot: low tens to low hundreds of dollars + small vector capacity.</a:t>
+              <a:t>Monthly Dev pilot (~200 questions/day): roughly $50-$150 + ~$10-$30 small vector storage.</a:t>
             </a:r>
           </a:p>
           <a:p>
             <a:r>
               <a:rPr lang="en-US" sz="2400" dirty="0"/>
-              <a:t>Levers: re-embed only changed docs; cap top_k &amp; context; Haiku for classify / Sonnet for answers; AWS Budgets hard cap.</a:t>
+              <a:t>Guardrails/levers: AWS Budgets hard cap (spend cannot exceed the ceiling); cheaper model for simple steps; cap context size. Figures are planning estimates - confirmed against real doc counts + current Bedrock rates before the pilot.</a:t>
             </a:r>
           </a:p>
         </p:txBody>

</xml_diff>

<commit_message>
Clarify deck cost slide (slide 12) with ballpark numbers (#13)
Replaced vague 'tens of dollars' / 'a few times that' with concrete planning estimates:
- One-time setup (embed all docs): ~$5-$20, once; then only changed docs
- Per question: ~1-3 cents (Option 1 / RAG), ~4-10 cents (Option 2 / Agentic)
- Monthly Dev pilot (~200 q/day): ~$50-$150 + ~$10-$30 vector storage
- Guardrail: AWS Budgets hard cap; estimates to be confirmed vs real doc counts + Bedrock rates
Still $0 today. Valid Microsoft PowerPoint 2007+.

Co-authored-by: Kiro Agent <agent@kiro.dev>
</commit_message>
<xml_diff>
--- a/SPARKS_AI_Search_Deck.pptx
+++ b/SPARKS_AI_Search_Deck.pptx
@@ -4535,25 +4535,25 @@
           <a:p>
             <a:r>
               <a:rPr lang="en-US" sz="2400" dirty="0"/>
-              <a:t>After approval (Dev pilot, estimates): one-time embedding ~tens of dollars (one time).</a:t>
+              <a:t>One-time setup (embed all docs): about $5-$20 total, once - then only changed docs re-embed (pennies).</a:t>
             </a:r>
           </a:p>
           <a:p>
             <a:r>
               <a:rPr lang="en-US" sz="2400" dirty="0"/>
-              <a:t>Per query: cents (Option 1); a few times that for Option 2 (more LLM turns).</a:t>
+              <a:t>Per question: ~1-3 cents (Option 1 / RAG); ~4-10 cents (Option 2 / Agentic - more LLM turns).</a:t>
             </a:r>
           </a:p>
           <a:p>
             <a:r>
               <a:rPr lang="en-US" sz="2400" dirty="0"/>
-              <a:t>Monthly Dev pilot: low tens to low hundreds of dollars + small vector capacity.</a:t>
+              <a:t>Monthly Dev pilot (~200 questions/day): roughly $50-$150 + ~$10-$30 small vector storage.</a:t>
             </a:r>
           </a:p>
           <a:p>
             <a:r>
               <a:rPr lang="en-US" sz="2400" dirty="0"/>
-              <a:t>Levers: re-embed only changed docs; cap top_k &amp; context; Haiku for classify / Sonnet for answers; AWS Budgets hard cap.</a:t>
+              <a:t>Guardrails/levers: AWS Budgets hard cap (spend cannot exceed the ceiling); cheaper model for simple steps; cap context size. Figures are planning estimates - confirmed against real doc counts + current Bedrock rates before the pilot.</a:t>
             </a:r>
           </a:p>
         </p:txBody>

</xml_diff>